<commit_message>
Added a study of how the number of steps after a limit cycle has been arrived at depends on D
</commit_message>
<xml_diff>
--- a/Sample code/Figure 6. Growth and ablation/Figure - growth_and_ablation.pptx
+++ b/Sample code/Figure 6. Growth and ablation/Figure - growth_and_ablation.pptx
@@ -260,7 +260,7 @@
           <a:p>
             <a:fld id="{7918679B-5683-0049-8DD0-2AC74A9489F6}" type="datetimeFigureOut">
               <a:rPr lang="en-US" smtClean="0"/>
-              <a:t>9/1/26</a:t>
+              <a:t>9/2/26</a:t>
             </a:fld>
             <a:endParaRPr lang="en-US"/>
           </a:p>
@@ -458,7 +458,7 @@
           <a:p>
             <a:fld id="{7918679B-5683-0049-8DD0-2AC74A9489F6}" type="datetimeFigureOut">
               <a:rPr lang="en-US" smtClean="0"/>
-              <a:t>9/1/26</a:t>
+              <a:t>9/2/26</a:t>
             </a:fld>
             <a:endParaRPr lang="en-US"/>
           </a:p>
@@ -666,7 +666,7 @@
           <a:p>
             <a:fld id="{7918679B-5683-0049-8DD0-2AC74A9489F6}" type="datetimeFigureOut">
               <a:rPr lang="en-US" smtClean="0"/>
-              <a:t>9/1/26</a:t>
+              <a:t>9/2/26</a:t>
             </a:fld>
             <a:endParaRPr lang="en-US"/>
           </a:p>
@@ -864,7 +864,7 @@
           <a:p>
             <a:fld id="{7918679B-5683-0049-8DD0-2AC74A9489F6}" type="datetimeFigureOut">
               <a:rPr lang="en-US" smtClean="0"/>
-              <a:t>9/1/26</a:t>
+              <a:t>9/2/26</a:t>
             </a:fld>
             <a:endParaRPr lang="en-US"/>
           </a:p>
@@ -1139,7 +1139,7 @@
           <a:p>
             <a:fld id="{7918679B-5683-0049-8DD0-2AC74A9489F6}" type="datetimeFigureOut">
               <a:rPr lang="en-US" smtClean="0"/>
-              <a:t>9/1/26</a:t>
+              <a:t>9/2/26</a:t>
             </a:fld>
             <a:endParaRPr lang="en-US"/>
           </a:p>
@@ -1404,7 +1404,7 @@
           <a:p>
             <a:fld id="{7918679B-5683-0049-8DD0-2AC74A9489F6}" type="datetimeFigureOut">
               <a:rPr lang="en-US" smtClean="0"/>
-              <a:t>9/1/26</a:t>
+              <a:t>9/2/26</a:t>
             </a:fld>
             <a:endParaRPr lang="en-US"/>
           </a:p>
@@ -1816,7 +1816,7 @@
           <a:p>
             <a:fld id="{7918679B-5683-0049-8DD0-2AC74A9489F6}" type="datetimeFigureOut">
               <a:rPr lang="en-US" smtClean="0"/>
-              <a:t>9/1/26</a:t>
+              <a:t>9/2/26</a:t>
             </a:fld>
             <a:endParaRPr lang="en-US"/>
           </a:p>
@@ -1957,7 +1957,7 @@
           <a:p>
             <a:fld id="{7918679B-5683-0049-8DD0-2AC74A9489F6}" type="datetimeFigureOut">
               <a:rPr lang="en-US" smtClean="0"/>
-              <a:t>9/1/26</a:t>
+              <a:t>9/2/26</a:t>
             </a:fld>
             <a:endParaRPr lang="en-US"/>
           </a:p>
@@ -2070,7 +2070,7 @@
           <a:p>
             <a:fld id="{7918679B-5683-0049-8DD0-2AC74A9489F6}" type="datetimeFigureOut">
               <a:rPr lang="en-US" smtClean="0"/>
-              <a:t>9/1/26</a:t>
+              <a:t>9/2/26</a:t>
             </a:fld>
             <a:endParaRPr lang="en-US"/>
           </a:p>
@@ -2381,7 +2381,7 @@
           <a:p>
             <a:fld id="{7918679B-5683-0049-8DD0-2AC74A9489F6}" type="datetimeFigureOut">
               <a:rPr lang="en-US" smtClean="0"/>
-              <a:t>9/1/26</a:t>
+              <a:t>9/2/26</a:t>
             </a:fld>
             <a:endParaRPr lang="en-US"/>
           </a:p>
@@ -2669,7 +2669,7 @@
           <a:p>
             <a:fld id="{7918679B-5683-0049-8DD0-2AC74A9489F6}" type="datetimeFigureOut">
               <a:rPr lang="en-US" smtClean="0"/>
-              <a:t>9/1/26</a:t>
+              <a:t>9/2/26</a:t>
             </a:fld>
             <a:endParaRPr lang="en-US"/>
           </a:p>
@@ -2910,7 +2910,7 @@
           <a:p>
             <a:fld id="{7918679B-5683-0049-8DD0-2AC74A9489F6}" type="datetimeFigureOut">
               <a:rPr lang="en-US" smtClean="0"/>
-              <a:t>9/1/26</a:t>
+              <a:t>9/2/26</a:t>
             </a:fld>
             <a:endParaRPr lang="en-US"/>
           </a:p>
@@ -3327,36 +3327,6 @@
           <a:chExt cx="0" cy="0"/>
         </a:xfrm>
       </p:grpSpPr>
-      <p:pic>
-        <p:nvPicPr>
-          <p:cNvPr id="3" name="Picture 2">
-            <a:extLst>
-              <a:ext uri="{FF2B5EF4-FFF2-40B4-BE49-F238E27FC236}">
-                <a16:creationId xmlns:a16="http://schemas.microsoft.com/office/drawing/2014/main" id="{A5973A04-7622-EA1F-2A02-BAA45E395296}"/>
-              </a:ext>
-            </a:extLst>
-          </p:cNvPr>
-          <p:cNvPicPr>
-            <a:picLocks noChangeAspect="1"/>
-          </p:cNvPicPr>
-          <p:nvPr/>
-        </p:nvPicPr>
-        <p:blipFill>
-          <a:blip r:embed="rId2"/>
-          <a:stretch>
-            <a:fillRect/>
-          </a:stretch>
-        </p:blipFill>
-        <p:spPr>
-          <a:xfrm>
-            <a:off x="642608" y="1971909"/>
-            <a:ext cx="4476762" cy="2238381"/>
-          </a:xfrm>
-          <a:prstGeom prst="rect">
-            <a:avLst/>
-          </a:prstGeom>
-        </p:spPr>
-      </p:pic>
       <p:grpSp>
         <p:nvGrpSpPr>
           <p:cNvPr id="18" name="Group 17">
@@ -3501,7 +3471,7 @@
           <p:nvPr/>
         </p:nvPicPr>
         <p:blipFill>
-          <a:blip r:embed="rId3"/>
+          <a:blip r:embed="rId2"/>
           <a:stretch>
             <a:fillRect/>
           </a:stretch>
@@ -3518,10 +3488,40 @@
       </p:pic>
       <p:pic>
         <p:nvPicPr>
-          <p:cNvPr id="13" name="Picture 12">
-            <a:extLst>
-              <a:ext uri="{FF2B5EF4-FFF2-40B4-BE49-F238E27FC236}">
-                <a16:creationId xmlns:a16="http://schemas.microsoft.com/office/drawing/2014/main" id="{15897F97-2B00-B53B-3B76-B869095E51DB}"/>
+          <p:cNvPr id="2" name="Picture 1">
+            <a:extLst>
+              <a:ext uri="{FF2B5EF4-FFF2-40B4-BE49-F238E27FC236}">
+                <a16:creationId xmlns:a16="http://schemas.microsoft.com/office/drawing/2014/main" id="{2EBF3DD6-5020-D9F5-1CD5-DB1D3083A045}"/>
+              </a:ext>
+            </a:extLst>
+          </p:cNvPr>
+          <p:cNvPicPr>
+            <a:picLocks noChangeAspect="1"/>
+          </p:cNvPicPr>
+          <p:nvPr/>
+        </p:nvPicPr>
+        <p:blipFill>
+          <a:blip r:embed="rId3"/>
+          <a:stretch>
+            <a:fillRect/>
+          </a:stretch>
+        </p:blipFill>
+        <p:spPr>
+          <a:xfrm>
+            <a:off x="684641" y="2427973"/>
+            <a:ext cx="4084182" cy="1815192"/>
+          </a:xfrm>
+          <a:prstGeom prst="rect">
+            <a:avLst/>
+          </a:prstGeom>
+        </p:spPr>
+      </p:pic>
+      <p:pic>
+        <p:nvPicPr>
+          <p:cNvPr id="4" name="Picture 3">
+            <a:extLst>
+              <a:ext uri="{FF2B5EF4-FFF2-40B4-BE49-F238E27FC236}">
+                <a16:creationId xmlns:a16="http://schemas.microsoft.com/office/drawing/2014/main" id="{1837E5BC-8658-B1F2-A475-9C1829739A35}"/>
               </a:ext>
             </a:extLst>
           </p:cNvPr>
@@ -3538,8 +3538,8 @@
         </p:blipFill>
         <p:spPr>
           <a:xfrm>
-            <a:off x="712873" y="318264"/>
-            <a:ext cx="4119005" cy="1783367"/>
+            <a:off x="684641" y="342381"/>
+            <a:ext cx="4084182" cy="1815192"/>
           </a:xfrm>
           <a:prstGeom prst="rect">
             <a:avLst/>

</xml_diff>